<commit_message>
auto: vault-sync 2026-05-14T12:13:55Z (13 files)
</commit_message>
<xml_diff>
--- a/vault/courses/gemini-enterprise-agents/ch07-slides.pptx
+++ b/vault/courses/gemini-enterprise-agents/ch07-slides.pptx
@@ -12,7 +12,6 @@
     <p:sldId id="260" r:id="rId11"/>
     <p:sldId id="261" r:id="rId12"/>
     <p:sldId id="262" r:id="rId13"/>
-    <p:sldId id="263" r:id="rId14"/>
   </p:sldIdLst>
   <p:sldSz cx="12191695" cy="6858000" type="screen4x3"/>
   <p:notesSz cx="6858000" cy="9144000"/>
@@ -3112,7 +3111,7 @@
         <p:spPr>
           <a:xfrm>
             <a:off x="822960" y="1051560"/>
-            <a:ext cx="10515600" cy="594360"/>
+            <a:ext cx="10515600" cy="822960"/>
           </a:xfrm>
           <a:prstGeom prst="rect">
             <a:avLst/>
@@ -3145,8 +3144,8 @@
         </p:nvSpPr>
         <p:spPr>
           <a:xfrm>
-            <a:off x="1143000" y="1828800"/>
-            <a:ext cx="9875520" cy="868680"/>
+            <a:off x="1143000" y="2057400"/>
+            <a:ext cx="9875520" cy="411480"/>
           </a:xfrm>
           <a:prstGeom prst="rect">
             <a:avLst/>
@@ -3161,12 +3160,12 @@
           <a:p>
             <a:pPr algn="ctr"/>
             <a:r>
-              <a:rPr sz="2400" b="0">
-                <a:solidFill>
-                  <a:srgbClr val="A1A1AA"/>
+              <a:rPr sz="1600" b="0">
+                <a:solidFill>
+                  <a:srgbClr val="FFFFFF"/>
                 </a:solidFill>
               </a:rPr>
-              <a:t>Throughput, Quotas, Autoscaling, and Cost Attribution</a:t>
+              <a:t>Chapter 7 · Gemini Enterprise Agents</a:t>
             </a:r>
           </a:p>
         </p:txBody>
@@ -3179,8 +3178,8 @@
         </p:nvSpPr>
         <p:spPr>
           <a:xfrm>
-            <a:off x="1143000" y="2907792"/>
-            <a:ext cx="9875520" cy="411480"/>
+            <a:off x="1417320" y="2971800"/>
+            <a:ext cx="9326880" cy="868680"/>
           </a:xfrm>
           <a:prstGeom prst="rect">
             <a:avLst/>
@@ -3195,12 +3194,12 @@
           <a:p>
             <a:pPr algn="ctr"/>
             <a:r>
-              <a:rPr sz="1600" b="0">
-                <a:solidFill>
-                  <a:srgbClr val="FFFFFF"/>
+              <a:rPr sz="1800" b="0">
+                <a:solidFill>
+                  <a:srgbClr val="A1A1AA"/>
                 </a:solidFill>
               </a:rPr>
-              <a:t>Chapter 7 · Gemini Enterprise Agents</a:t>
+              <a:t>Five production levers for controllable economics: throughput commitments, endpoint strategy, batch work, quota guardrails, and chargeback labels.</a:t>
             </a:r>
           </a:p>
         </p:txBody>
@@ -3208,40 +3207,6 @@
       <p:sp>
         <p:nvSpPr>
           <p:cNvPr id="5" name="TextBox 4"/>
-          <p:cNvSpPr txBox="1"/>
-          <p:nvPr/>
-        </p:nvSpPr>
-        <p:spPr>
-          <a:xfrm>
-            <a:off x="1417320" y="3794760"/>
-            <a:ext cx="9326880" cy="868680"/>
-          </a:xfrm>
-          <a:prstGeom prst="rect">
-            <a:avLst/>
-          </a:prstGeom>
-          <a:noFill/>
-        </p:spPr>
-        <p:txBody>
-          <a:bodyPr wrap="square" lIns="18288" rIns="18288">
-            <a:normAutofit/>
-          </a:bodyPr>
-          <a:lstStyle/>
-          <a:p>
-            <a:pPr algn="ctr"/>
-            <a:r>
-              <a:rPr sz="1800" b="0">
-                <a:solidFill>
-                  <a:srgbClr val="FFFFFF"/>
-                </a:solidFill>
-              </a:rPr>
-              <a:t>The five levers that keep production agent economics defensible: throughput commitments, endpoint choice, batch work, quota guardrails, and chargeback labels.</a:t>
-            </a:r>
-          </a:p>
-        </p:txBody>
-      </p:sp>
-      <p:sp>
-        <p:nvSpPr>
-          <p:cNvPr id="6" name="TextBox 5"/>
           <p:cNvSpPr txBox="1"/>
           <p:nvPr/>
         </p:nvSpPr>
@@ -3448,7 +3413,7 @@
                   <a:srgbClr val="FFFFFF"/>
                 </a:solidFill>
               </a:rPr>
-              <a:t>Choose Provisioned Throughput or on-demand pricing from a measured workload, not a guess.</a:t>
+              <a:t>Choose Provisioned Throughput or on-demand pricing from measured workload shape and SLO needs.</a:t>
             </a:r>
           </a:p>
         </p:txBody>
@@ -3525,7 +3490,7 @@
                   <a:srgbClr val="FFFFFF"/>
                 </a:solidFill>
               </a:rPr>
-              <a:t>Pick regional or global Vertex AI endpoints based on latency, failover, and residency constraints.</a:t>
+              <a:t>Pick regional versus global inference endpoints based on residency, failover, and latency tradeoffs.</a:t>
             </a:r>
           </a:p>
         </p:txBody>
@@ -3602,7 +3567,7 @@
                   <a:srgbClr val="FFFFFF"/>
                 </a:solidFill>
               </a:rPr>
-              <a:t>Use batch prediction for offline sub-tasks that can trade latency for a 50% token discount.</a:t>
+              <a:t>Move non-urgent sub-tasks to batch prediction to cut online token spend and keep user latency low.</a:t>
             </a:r>
           </a:p>
         </p:txBody>
@@ -3679,7 +3644,7 @@
                   <a:srgbClr val="FFFFFF"/>
                 </a:solidFill>
               </a:rPr>
-              <a:t>Configure project, agent, and tenant limits to stop runaway loops before they become spend incidents.</a:t>
+              <a:t>Set project, agent, and tenant limits that stop runaway loops before they become incidents.</a:t>
             </a:r>
           </a:p>
         </p:txBody>
@@ -3756,7 +3721,7 @@
                   <a:srgbClr val="FFFFFF"/>
                 </a:solidFill>
               </a:rPr>
-              <a:t>Build per-team cost attribution with deployment labels, billing export, metrics, and audit logs.</a:t>
+              <a:t>Implement cost attribution labels and monthly chargeback queries finance can trust.</a:t>
             </a:r>
           </a:p>
         </p:txBody>
@@ -3884,7 +3849,7 @@
                   <a:srgbClr val="FFFFFF"/>
                 </a:solidFill>
               </a:rPr>
-              <a:t>The unit economics that actually matter</a:t>
+              <a:t>The unit economics that matter</a:t>
             </a:r>
           </a:p>
         </p:txBody>
@@ -4081,7 +4046,7 @@
                   <a:srgbClr val="FFFFFF"/>
                 </a:solidFill>
               </a:rPr>
-              <a:t>Cost-per-resolved-task catches retries, handoffs, abandoned conversations, and useful outcomes.</a:t>
+              <a:t>Cost-per-resolved-task includes retries, handoffs, and abandoned sessions that invocation metrics hide.</a:t>
             </a:r>
           </a:p>
         </p:txBody>
@@ -4158,7 +4123,7 @@
                   <a:srgbClr val="FFFFFF"/>
                 </a:solidFill>
               </a:rPr>
-              <a:t>A Koenig invoice pipeline measured $0.038 per invoice with Pro orchestration plus Flash sub-agents.</a:t>
+              <a:t>Illustrative chapter arithmetic shows mixed Pro + Flash routing can be about 3x cheaper than Pro-everywhere.</a:t>
             </a:r>
           </a:p>
         </p:txBody>
@@ -4235,7 +4200,7 @@
                   <a:srgbClr val="FFFFFF"/>
                 </a:solidFill>
               </a:rPr>
-              <a:t>The same workload with Pro everywhere measured $0.110 per invoice, a 2.9x cost increase.</a:t>
+              <a:t>Token list prices are only one lever; call-graph design and retry behavior often dominate total spend.</a:t>
             </a:r>
           </a:p>
         </p:txBody>
@@ -4312,7 +4277,7 @@
                   <a:srgbClr val="FFFFFF"/>
                 </a:solidFill>
               </a:rPr>
-              <a:t>Model selection is the largest lever, but only after the call graph is honest.</a:t>
+              <a:t>Optimization starts by removing unnecessary model calls, then tuning model mix and caching rules.</a:t>
             </a:r>
           </a:p>
         </p:txBody>
@@ -4560,7 +4525,7 @@
                   <a:srgbClr val="FFFFFF"/>
                 </a:solidFill>
               </a:rPr>
-              <a:t>Provisioned Throughput buys committed generation capacity in 100 token-per-second units.</a:t>
+              <a:t>Provisioned Throughput reserves generation capacity per model and region; you pay for commitment, not usage spikes.</a:t>
             </a:r>
           </a:p>
         </p:txBody>
@@ -4637,7 +4602,7 @@
                   <a:srgbClr val="FFFFFF"/>
                 </a:solidFill>
               </a:rPr>
-              <a:t>On-demand usually wins for low or spiky workloads because idle committed capacity is still paid for.</a:t>
+              <a:t>On-demand usually wins for low or highly spiky workloads where committed capacity would sit idle.</a:t>
             </a:r>
           </a:p>
         </p:txBody>
@@ -4714,7 +4679,7 @@
                   <a:srgbClr val="FFFFFF"/>
                 </a:solidFill>
               </a:rPr>
-              <a:t>PT becomes interesting for continuous workloads with strict p99 latency or fixed-budget procurement needs.</a:t>
+              <a:t>PT is most useful when p99 misses are caused by shared-capacity contention and traffic is sustained.</a:t>
             </a:r>
           </a:p>
         </p:txBody>
@@ -4791,7 +4756,7 @@
                   <a:srgbClr val="FFFFFF"/>
                 </a:solidFill>
               </a:rPr>
-              <a:t>In the chapter example, 25 output tokens/second costs about $518/month on-demand versus roughly $35K/month for one PT unit.</a:t>
+              <a:t>If p99 misses are tool-latency or prompt-size driven, PT does not fix the root cause.</a:t>
             </a:r>
           </a:p>
         </p:txBody>
@@ -4868,7 +4833,7 @@
                   <a:srgbClr val="FFFFFF"/>
                 </a:solidFill>
               </a:rPr>
-              <a:t>The decision depends on steady-state qps, spike shape, latency floor, and cost-predictability requirements.</a:t>
+              <a:t>Decide using steady-state TPS, traffic volatility, SLO pressure, and budget predictability requirements.</a:t>
             </a:r>
           </a:p>
         </p:txBody>
@@ -4996,7 +4961,7 @@
                   <a:srgbClr val="FFFFFF"/>
                 </a:solidFill>
               </a:rPr>
-              <a:t>Levers 2-3: Endpoint choice and batch work</a:t>
+              <a:t>Levers 2-3: Endpoint strategy and batch</a:t>
             </a:r>
           </a:p>
         </p:txBody>
@@ -5116,7 +5081,7 @@
                   <a:srgbClr val="FFFFFF"/>
                 </a:solidFill>
               </a:rPr>
-              <a:t>Global endpoints route to nearby healthy capacity and optimize for resilience and pooled throughput.</a:t>
+              <a:t>Global endpoint maximizes capacity flexibility, while regional endpoints keep processing location explicit.</a:t>
             </a:r>
           </a:p>
         </p:txBody>
@@ -5193,7 +5158,7 @@
                   <a:srgbClr val="FFFFFF"/>
                 </a:solidFill>
               </a:rPr>
-              <a:t>Regional endpoints pin inference to a region for residency, auditability, and co-located latency.</a:t>
+              <a:t>For residency or compliance controls, use regional endpoints and validate routing in the deployed environment.</a:t>
             </a:r>
           </a:p>
         </p:txBody>
@@ -5270,7 +5235,7 @@
                   <a:srgbClr val="FFFFFF"/>
                 </a:solidFill>
               </a:rPr>
-              <a:t>If the agent is regional but the Vertex endpoint is global, inference traffic can leave the intended boundary.</a:t>
+              <a:t>Batch prediction is for offline or delay-tolerant workloads that can trade immediacy for lower per-token cost.</a:t>
             </a:r>
           </a:p>
         </p:txBody>
@@ -5347,7 +5312,7 @@
                   <a:srgbClr val="FFFFFF"/>
                 </a:solidFill>
               </a:rPr>
-              <a:t>Batch prediction is right for document classification, bulk evaluations, and overnight enrichment jobs.</a:t>
+              <a:t>Split synchronous user-critical responses from asynchronous enrichment jobs to reduce real-time spend.</a:t>
             </a:r>
           </a:p>
         </p:txBody>
@@ -5424,7 +5389,7 @@
                   <a:srgbClr val="FFFFFF"/>
                 </a:solidFill>
               </a:rPr>
-              <a:t>Split the user-facing critical path from async enrichments so only latency-sensitive work pays real-time prices.</a:t>
+              <a:t>Keep the online path minimal; move heavy enrichment, backfills, and evaluations to scheduled batches.</a:t>
             </a:r>
           </a:p>
         </p:txBody>
@@ -5552,7 +5517,7 @@
                   <a:srgbClr val="FFFFFF"/>
                 </a:solidFill>
               </a:rPr>
-              <a:t>Lever 4: Quotas, rate limits, and loop protection</a:t>
+              <a:t>Levers 4-5: Quotas, autoscaling, attribution</a:t>
             </a:r>
           </a:p>
         </p:txBody>
@@ -5615,7 +5580,7 @@
             <a:avLst/>
           </a:prstGeom>
           <a:solidFill>
-            <a:srgbClr val="F59E0B"/>
+            <a:srgbClr val="22C55E"/>
           </a:solidFill>
           <a:ln>
             <a:noFill/>
@@ -5672,7 +5637,7 @@
                   <a:srgbClr val="FFFFFF"/>
                 </a:solidFill>
               </a:rPr>
-              <a:t>Project-level quotas protect total GCP project throughput and require capacity plans for increases.</a:t>
+              <a:t>Apply layered controls: project quotas, per-agent limits, and per-tenant caps in multi-tenant systems.</a:t>
             </a:r>
           </a:p>
         </p:txBody>
@@ -5692,7 +5657,7 @@
             <a:avLst/>
           </a:prstGeom>
           <a:solidFill>
-            <a:srgbClr val="F59E0B"/>
+            <a:srgbClr val="22C55E"/>
           </a:solidFill>
           <a:ln>
             <a:noFill/>
@@ -5749,7 +5714,7 @@
                   <a:srgbClr val="FFFFFF"/>
                 </a:solidFill>
               </a:rPr>
-              <a:t>Agent-level rate limits keep one misbehaving agent from consuming all available capacity.</a:t>
+              <a:t>Guardrail settings like handoff depth and concurrent invocations prevent recursive loop spend incidents.</a:t>
             </a:r>
           </a:p>
         </p:txBody>
@@ -5769,7 +5734,7 @@
             <a:avLst/>
           </a:prstGeom>
           <a:solidFill>
-            <a:srgbClr val="F59E0B"/>
+            <a:srgbClr val="22C55E"/>
           </a:solidFill>
           <a:ln>
             <a:noFill/>
@@ -5826,7 +5791,7 @@
                   <a:srgbClr val="FFFFFF"/>
                 </a:solidFill>
               </a:rPr>
-              <a:t>Per-tenant limits prevent one customer or end user from starving everyone else in a multi-tenant system.</a:t>
+              <a:t>Autoscaling from zero reduces idle cost; warm minimum replicas reduce first-request latency.</a:t>
             </a:r>
           </a:p>
         </p:txBody>
@@ -5846,7 +5811,7 @@
             <a:avLst/>
           </a:prstGeom>
           <a:solidFill>
-            <a:srgbClr val="F59E0B"/>
+            <a:srgbClr val="22C55E"/>
           </a:solidFill>
           <a:ln>
             <a:noFill/>
@@ -5903,7 +5868,7 @@
                   <a:srgbClr val="FFFFFF"/>
                 </a:solidFill>
               </a:rPr>
-              <a:t>Set concurrent invocation and handoff-depth limits before launch; they are free controls against recursive loops.</a:t>
+              <a:t>Tune min/max replicas, target concurrency, and idle timeout to actual traffic shape, not defaults.</a:t>
             </a:r>
           </a:p>
         </p:txBody>
@@ -5923,7 +5888,7 @@
             <a:avLst/>
           </a:prstGeom>
           <a:solidFill>
-            <a:srgbClr val="F59E0B"/>
+            <a:srgbClr val="22C55E"/>
           </a:solidFill>
           <a:ln>
             <a:noFill/>
@@ -5980,7 +5945,7 @@
                   <a:srgbClr val="FFFFFF"/>
                 </a:solidFill>
               </a:rPr>
-              <a:t>The chapter incident: a 14-minute sub-agent recursion loop produced $1,847 of unintended Gemini Pro spend.</a:t>
+              <a:t>Require deployment labels such as team, cost_center, and environment to support monthly chargeback.</a:t>
             </a:r>
           </a:p>
         </p:txBody>
@@ -6087,8 +6052,8 @@
         </p:nvSpPr>
         <p:spPr>
           <a:xfrm>
-            <a:off x="685800" y="411480"/>
-            <a:ext cx="10835640" cy="685800"/>
+            <a:off x="822960" y="640080"/>
+            <a:ext cx="10515600" cy="566928"/>
           </a:xfrm>
           <a:prstGeom prst="rect">
             <a:avLst/>
@@ -6101,114 +6066,28 @@
           </a:bodyPr>
           <a:lstStyle/>
           <a:p>
-            <a:pPr algn="l"/>
-            <a:r>
-              <a:rPr sz="2700" b="1">
+            <a:pPr algn="ctr"/>
+            <a:r>
+              <a:rPr sz="3400" b="1">
                 <a:solidFill>
                   <a:srgbClr val="FFFFFF"/>
                 </a:solidFill>
               </a:rPr>
-              <a:t>Levers 5-6: Autoscaling and cost attribution</a:t>
-            </a:r>
-          </a:p>
-        </p:txBody>
-      </p:sp>
-      <p:sp>
-        <p:nvSpPr>
-          <p:cNvPr id="3" name="Rectangle 2"/>
-          <p:cNvSpPr/>
-          <p:nvPr/>
-        </p:nvSpPr>
-        <p:spPr>
-          <a:xfrm>
-            <a:off x="685800" y="1344168"/>
-            <a:ext cx="10835640" cy="32004"/>
-          </a:xfrm>
-          <a:prstGeom prst="rect">
-            <a:avLst/>
-          </a:prstGeom>
-          <a:solidFill>
-            <a:srgbClr val="A1A1AA"/>
-          </a:solidFill>
-          <a:ln>
-            <a:noFill/>
-          </a:ln>
-        </p:spPr>
-        <p:style>
-          <a:lnRef idx="1">
-            <a:schemeClr val="accent1"/>
-          </a:lnRef>
-          <a:fillRef idx="3">
-            <a:schemeClr val="accent1"/>
-          </a:fillRef>
-          <a:effectRef idx="2">
-            <a:schemeClr val="accent1"/>
-          </a:effectRef>
-          <a:fontRef idx="minor">
-            <a:schemeClr val="lt1"/>
-          </a:fontRef>
-        </p:style>
-        <p:txBody>
-          <a:bodyPr rtlCol="0" anchor="ctr"/>
-          <a:lstStyle/>
-          <a:p>
-            <a:pPr algn="ctr"/>
-          </a:p>
-        </p:txBody>
-      </p:sp>
-      <p:sp>
-        <p:nvSpPr>
-          <p:cNvPr id="4" name="Oval 3"/>
-          <p:cNvSpPr/>
-          <p:nvPr/>
-        </p:nvSpPr>
-        <p:spPr>
-          <a:xfrm>
-            <a:off x="768096" y="1783080"/>
-            <a:ext cx="118872" cy="118872"/>
-          </a:xfrm>
-          <a:prstGeom prst="ellipse">
-            <a:avLst/>
-          </a:prstGeom>
-          <a:solidFill>
-            <a:srgbClr val="22C55E"/>
-          </a:solidFill>
-          <a:ln>
-            <a:noFill/>
-          </a:ln>
-        </p:spPr>
-        <p:style>
-          <a:lnRef idx="1">
-            <a:schemeClr val="accent1"/>
-          </a:lnRef>
-          <a:fillRef idx="3">
-            <a:schemeClr val="accent1"/>
-          </a:fillRef>
-          <a:effectRef idx="2">
-            <a:schemeClr val="accent1"/>
-          </a:effectRef>
-          <a:fontRef idx="minor">
-            <a:schemeClr val="lt1"/>
-          </a:fontRef>
-        </p:style>
-        <p:txBody>
-          <a:bodyPr rtlCol="0" anchor="ctr"/>
-          <a:lstStyle/>
-          <a:p>
-            <a:pPr algn="ctr"/>
-          </a:p>
-        </p:txBody>
-      </p:sp>
-      <p:sp>
-        <p:nvSpPr>
-          <p:cNvPr id="5" name="TextBox 4"/>
+              <a:t>Try it next</a:t>
+            </a:r>
+          </a:p>
+        </p:txBody>
+      </p:sp>
+      <p:sp>
+        <p:nvSpPr>
+          <p:cNvPr id="3" name="TextBox 2"/>
           <p:cNvSpPr txBox="1"/>
           <p:nvPr/>
         </p:nvSpPr>
         <p:spPr>
           <a:xfrm>
-            <a:off x="1024128" y="1664208"/>
-            <a:ext cx="10149840" cy="658368"/>
+            <a:off x="1097280" y="1481328"/>
+            <a:ext cx="9966960" cy="502920"/>
           </a:xfrm>
           <a:prstGeom prst="rect">
             <a:avLst/>
@@ -6221,71 +6100,28 @@
           </a:bodyPr>
           <a:lstStyle/>
           <a:p>
-            <a:pPr algn="l"/>
-            <a:r>
-              <a:rPr sz="1700" b="0">
-                <a:solidFill>
-                  <a:srgbClr val="FFFFFF"/>
+            <a:pPr algn="ctr"/>
+            <a:r>
+              <a:rPr sz="2000" b="0">
+                <a:solidFill>
+                  <a:srgbClr val="A1A1AA"/>
                 </a:solidFill>
               </a:rPr>
-              <a:t>Agent Runtime can scale from zero, but fully cold starts add roughly 5-9 seconds to first-request latency.</a:t>
-            </a:r>
-          </a:p>
-        </p:txBody>
-      </p:sp>
-      <p:sp>
-        <p:nvSpPr>
-          <p:cNvPr id="6" name="Oval 5"/>
-          <p:cNvSpPr/>
-          <p:nvPr/>
-        </p:nvSpPr>
-        <p:spPr>
-          <a:xfrm>
-            <a:off x="768096" y="2532888"/>
-            <a:ext cx="118872" cy="118872"/>
-          </a:xfrm>
-          <a:prstGeom prst="ellipse">
-            <a:avLst/>
-          </a:prstGeom>
-          <a:solidFill>
-            <a:srgbClr val="22C55E"/>
-          </a:solidFill>
-          <a:ln>
-            <a:noFill/>
-          </a:ln>
-        </p:spPr>
-        <p:style>
-          <a:lnRef idx="1">
-            <a:schemeClr val="accent1"/>
-          </a:lnRef>
-          <a:fillRef idx="3">
-            <a:schemeClr val="accent1"/>
-          </a:fillRef>
-          <a:effectRef idx="2">
-            <a:schemeClr val="accent1"/>
-          </a:effectRef>
-          <a:fontRef idx="minor">
-            <a:schemeClr val="lt1"/>
-          </a:fontRef>
-        </p:style>
-        <p:txBody>
-          <a:bodyPr rtlCol="0" anchor="ctr"/>
-          <a:lstStyle/>
-          <a:p>
-            <a:pPr algn="ctr"/>
-          </a:p>
-        </p:txBody>
-      </p:sp>
-      <p:sp>
-        <p:nvSpPr>
-          <p:cNvPr id="7" name="TextBox 6"/>
+              <a:t>Build the Chapter 6 invoice pipeline runbook using Chapter 7 controls.</a:t>
+            </a:r>
+          </a:p>
+        </p:txBody>
+      </p:sp>
+      <p:sp>
+        <p:nvSpPr>
+          <p:cNvPr id="4" name="TextBox 3"/>
           <p:cNvSpPr txBox="1"/>
           <p:nvPr/>
         </p:nvSpPr>
         <p:spPr>
           <a:xfrm>
-            <a:off x="1024128" y="2414016"/>
-            <a:ext cx="10149840" cy="658368"/>
+            <a:off x="1234440" y="2331720"/>
+            <a:ext cx="320040" cy="320040"/>
           </a:xfrm>
           <a:prstGeom prst="rect">
             <a:avLst/>
@@ -6298,71 +6134,28 @@
           </a:bodyPr>
           <a:lstStyle/>
           <a:p>
-            <a:pPr algn="l"/>
-            <a:r>
-              <a:rPr sz="1700" b="0">
-                <a:solidFill>
-                  <a:srgbClr val="FFFFFF"/>
+            <a:pPr algn="ctr"/>
+            <a:r>
+              <a:rPr sz="1700" b="1">
+                <a:solidFill>
+                  <a:srgbClr val="A1A1AA"/>
                 </a:solidFill>
               </a:rPr>
-              <a:t>Use min_replicas for latency-sensitive, 24/7 agents; use scale-to-zero for quiet internal tools.</a:t>
-            </a:r>
-          </a:p>
-        </p:txBody>
-      </p:sp>
-      <p:sp>
-        <p:nvSpPr>
-          <p:cNvPr id="8" name="Oval 7"/>
-          <p:cNvSpPr/>
-          <p:nvPr/>
-        </p:nvSpPr>
-        <p:spPr>
-          <a:xfrm>
-            <a:off x="768096" y="3282696"/>
-            <a:ext cx="118872" cy="118872"/>
-          </a:xfrm>
-          <a:prstGeom prst="ellipse">
-            <a:avLst/>
-          </a:prstGeom>
-          <a:solidFill>
-            <a:srgbClr val="22C55E"/>
-          </a:solidFill>
-          <a:ln>
-            <a:noFill/>
-          </a:ln>
-        </p:spPr>
-        <p:style>
-          <a:lnRef idx="1">
-            <a:schemeClr val="accent1"/>
-          </a:lnRef>
-          <a:fillRef idx="3">
-            <a:schemeClr val="accent1"/>
-          </a:fillRef>
-          <a:effectRef idx="2">
-            <a:schemeClr val="accent1"/>
-          </a:effectRef>
-          <a:fontRef idx="minor">
-            <a:schemeClr val="lt1"/>
-          </a:fontRef>
-        </p:style>
-        <p:txBody>
-          <a:bodyPr rtlCol="0" anchor="ctr"/>
-          <a:lstStyle/>
-          <a:p>
-            <a:pPr algn="ctr"/>
-          </a:p>
-        </p:txBody>
-      </p:sp>
-      <p:sp>
-        <p:nvSpPr>
-          <p:cNvPr id="9" name="TextBox 8"/>
+              <a:t>1</a:t>
+            </a:r>
+          </a:p>
+        </p:txBody>
+      </p:sp>
+      <p:sp>
+        <p:nvSpPr>
+          <p:cNvPr id="5" name="TextBox 4"/>
           <p:cNvSpPr txBox="1"/>
           <p:nvPr/>
         </p:nvSpPr>
         <p:spPr>
           <a:xfrm>
-            <a:off x="1024128" y="3163824"/>
-            <a:ext cx="10149840" cy="658368"/>
+            <a:off x="1700784" y="2304288"/>
+            <a:ext cx="9144000" cy="502920"/>
           </a:xfrm>
           <a:prstGeom prst="rect">
             <a:avLst/>
@@ -6382,64 +6175,21 @@
                   <a:srgbClr val="FFFFFF"/>
                 </a:solidFill>
               </a:rPr>
-              <a:t>Target concurrency and idle timeout should mirror the traffic shape, not a default copied from another service.</a:t>
-            </a:r>
-          </a:p>
-        </p:txBody>
-      </p:sp>
-      <p:sp>
-        <p:nvSpPr>
-          <p:cNvPr id="10" name="Oval 9"/>
-          <p:cNvSpPr/>
-          <p:nvPr/>
-        </p:nvSpPr>
-        <p:spPr>
-          <a:xfrm>
-            <a:off x="768096" y="4032504"/>
-            <a:ext cx="118872" cy="118872"/>
-          </a:xfrm>
-          <a:prstGeom prst="ellipse">
-            <a:avLst/>
-          </a:prstGeom>
-          <a:solidFill>
-            <a:srgbClr val="22C55E"/>
-          </a:solidFill>
-          <a:ln>
-            <a:noFill/>
-          </a:ln>
-        </p:spPr>
-        <p:style>
-          <a:lnRef idx="1">
-            <a:schemeClr val="accent1"/>
-          </a:lnRef>
-          <a:fillRef idx="3">
-            <a:schemeClr val="accent1"/>
-          </a:fillRef>
-          <a:effectRef idx="2">
-            <a:schemeClr val="accent1"/>
-          </a:effectRef>
-          <a:fontRef idx="minor">
-            <a:schemeClr val="lt1"/>
-          </a:fontRef>
-        </p:style>
-        <p:txBody>
-          <a:bodyPr rtlCol="0" anchor="ctr"/>
-          <a:lstStyle/>
-          <a:p>
-            <a:pPr algn="ctr"/>
-          </a:p>
-        </p:txBody>
-      </p:sp>
-      <p:sp>
-        <p:nvSpPr>
-          <p:cNvPr id="11" name="TextBox 10"/>
+              <a:t>Define p50, p99, availability, and cost-per-invoice targets with explicit rationale.</a:t>
+            </a:r>
+          </a:p>
+        </p:txBody>
+      </p:sp>
+      <p:sp>
+        <p:nvSpPr>
+          <p:cNvPr id="6" name="TextBox 5"/>
           <p:cNvSpPr txBox="1"/>
           <p:nvPr/>
         </p:nvSpPr>
         <p:spPr>
           <a:xfrm>
-            <a:off x="1024128" y="3913632"/>
-            <a:ext cx="10149840" cy="658368"/>
+            <a:off x="1234440" y="2990087"/>
+            <a:ext cx="320040" cy="320040"/>
           </a:xfrm>
           <a:prstGeom prst="rect">
             <a:avLst/>
@@ -6452,71 +6202,28 @@
           </a:bodyPr>
           <a:lstStyle/>
           <a:p>
-            <a:pPr algn="l"/>
-            <a:r>
-              <a:rPr sz="1700" b="0">
-                <a:solidFill>
-                  <a:srgbClr val="FFFFFF"/>
+            <a:pPr algn="ctr"/>
+            <a:r>
+              <a:rPr sz="1700" b="1">
+                <a:solidFill>
+                  <a:srgbClr val="A1A1AA"/>
                 </a:solidFill>
               </a:rPr>
-              <a:t>Require team, cost_center, and environment labels on every deployment so billing export can support chargeback.</a:t>
-            </a:r>
-          </a:p>
-        </p:txBody>
-      </p:sp>
-      <p:sp>
-        <p:nvSpPr>
-          <p:cNvPr id="12" name="Oval 11"/>
-          <p:cNvSpPr/>
-          <p:nvPr/>
-        </p:nvSpPr>
-        <p:spPr>
-          <a:xfrm>
-            <a:off x="768096" y="4782312"/>
-            <a:ext cx="118872" cy="118872"/>
-          </a:xfrm>
-          <a:prstGeom prst="ellipse">
-            <a:avLst/>
-          </a:prstGeom>
-          <a:solidFill>
-            <a:srgbClr val="22C55E"/>
-          </a:solidFill>
-          <a:ln>
-            <a:noFill/>
-          </a:ln>
-        </p:spPr>
-        <p:style>
-          <a:lnRef idx="1">
-            <a:schemeClr val="accent1"/>
-          </a:lnRef>
-          <a:fillRef idx="3">
-            <a:schemeClr val="accent1"/>
-          </a:fillRef>
-          <a:effectRef idx="2">
-            <a:schemeClr val="accent1"/>
-          </a:effectRef>
-          <a:fontRef idx="minor">
-            <a:schemeClr val="lt1"/>
-          </a:fontRef>
-        </p:style>
-        <p:txBody>
-          <a:bodyPr rtlCol="0" anchor="ctr"/>
-          <a:lstStyle/>
-          <a:p>
-            <a:pPr algn="ctr"/>
-          </a:p>
-        </p:txBody>
-      </p:sp>
-      <p:sp>
-        <p:nvSpPr>
-          <p:cNvPr id="13" name="TextBox 12"/>
+              <a:t>2</a:t>
+            </a:r>
+          </a:p>
+        </p:txBody>
+      </p:sp>
+      <p:sp>
+        <p:nvSpPr>
+          <p:cNvPr id="7" name="TextBox 6"/>
           <p:cNvSpPr txBox="1"/>
           <p:nvPr/>
         </p:nvSpPr>
         <p:spPr>
           <a:xfrm>
-            <a:off x="1024128" y="4663440"/>
-            <a:ext cx="10149840" cy="658368"/>
+            <a:off x="1700784" y="2962656"/>
+            <a:ext cx="9144000" cy="502920"/>
           </a:xfrm>
           <a:prstGeom prst="rect">
             <a:avLst/>
@@ -6536,21 +6243,21 @@
                   <a:srgbClr val="FFFFFF"/>
                 </a:solidFill>
               </a:rPr>
-              <a:t>Untagged spend should land on the platform budget to create an incentive for label compliance.</a:t>
-            </a:r>
-          </a:p>
-        </p:txBody>
-      </p:sp>
-      <p:sp>
-        <p:nvSpPr>
-          <p:cNvPr id="14" name="TextBox 13"/>
+              <a:t>Map when PT becomes rational for your traffic profile and where on-demand remains better.</a:t>
+            </a:r>
+          </a:p>
+        </p:txBody>
+      </p:sp>
+      <p:sp>
+        <p:nvSpPr>
+          <p:cNvPr id="8" name="TextBox 7"/>
           <p:cNvSpPr txBox="1"/>
           <p:nvPr/>
         </p:nvSpPr>
         <p:spPr>
           <a:xfrm>
-            <a:off x="685800" y="6327648"/>
-            <a:ext cx="5669280" cy="256032"/>
+            <a:off x="1234440" y="3648455"/>
+            <a:ext cx="320040" cy="320040"/>
           </a:xfrm>
           <a:prstGeom prst="rect">
             <a:avLst/>
@@ -6563,28 +6270,28 @@
           </a:bodyPr>
           <a:lstStyle/>
           <a:p>
-            <a:pPr algn="l"/>
-            <a:r>
-              <a:rPr sz="900" b="0">
+            <a:pPr algn="ctr"/>
+            <a:r>
+              <a:rPr sz="1700" b="1">
                 <a:solidFill>
                   <a:srgbClr val="A1A1AA"/>
                 </a:solidFill>
               </a:rPr>
-              <a:t>academy.kspl.tech | Koenig AI Academy</a:t>
-            </a:r>
-          </a:p>
-        </p:txBody>
-      </p:sp>
-      <p:sp>
-        <p:nvSpPr>
-          <p:cNvPr id="15" name="TextBox 14"/>
+              <a:t>3</a:t>
+            </a:r>
+          </a:p>
+        </p:txBody>
+      </p:sp>
+      <p:sp>
+        <p:nvSpPr>
+          <p:cNvPr id="9" name="TextBox 8"/>
           <p:cNvSpPr txBox="1"/>
           <p:nvPr/>
         </p:nvSpPr>
         <p:spPr>
           <a:xfrm>
-            <a:off x="5897880" y="6327648"/>
-            <a:ext cx="5577840" cy="256032"/>
+            <a:off x="1700784" y="3621023"/>
+            <a:ext cx="9144000" cy="502920"/>
           </a:xfrm>
           <a:prstGeom prst="rect">
             <a:avLst/>
@@ -6597,54 +6304,28 @@
           </a:bodyPr>
           <a:lstStyle/>
           <a:p>
-            <a:pPr algn="r"/>
-            <a:r>
-              <a:rPr sz="900" b="0">
-                <a:solidFill>
-                  <a:srgbClr val="A1A1AA"/>
+            <a:pPr algn="l"/>
+            <a:r>
+              <a:rPr sz="1700" b="0">
+                <a:solidFill>
+                  <a:srgbClr val="FFFFFF"/>
                 </a:solidFill>
               </a:rPr>
-              <a:t>Gemini Enterprise Agents · Chapter 7</a:t>
-            </a:r>
-          </a:p>
-        </p:txBody>
-      </p:sp>
-    </p:spTree>
-  </p:cSld>
-  <p:clrMapOvr>
-    <a:masterClrMapping/>
-  </p:clrMapOvr>
-</p:sld>
-</file>
-
-<file path=ppt/slides/slide8.xml><?xml version="1.0" encoding="utf-8"?>
-<p:sld xmlns:a="http://schemas.openxmlformats.org/drawingml/2006/main" xmlns:p="http://schemas.openxmlformats.org/presentationml/2006/main" xmlns:r="http://schemas.openxmlformats.org/officeDocument/2006/relationships">
-  <p:cSld>
-    <p:bg>
-      <p:bgPr>
-        <a:solidFill>
-          <a:srgbClr val="18181B"/>
-        </a:solidFill>
-        <a:effectLst/>
-      </p:bgPr>
-    </p:bg>
-    <p:spTree>
-      <p:nvGrpSpPr>
-        <p:cNvPr id="1" name=""/>
-        <p:cNvGrpSpPr/>
-        <p:nvPr/>
-      </p:nvGrpSpPr>
-      <p:grpSpPr/>
-      <p:sp>
-        <p:nvSpPr>
-          <p:cNvPr id="2" name="TextBox 1"/>
+              <a:t>Specify quota limits, autoscaling profile, and tenant protections before launch.</a:t>
+            </a:r>
+          </a:p>
+        </p:txBody>
+      </p:sp>
+      <p:sp>
+        <p:nvSpPr>
+          <p:cNvPr id="10" name="TextBox 9"/>
           <p:cNvSpPr txBox="1"/>
           <p:nvPr/>
         </p:nvSpPr>
         <p:spPr>
           <a:xfrm>
-            <a:off x="822960" y="640080"/>
-            <a:ext cx="10515600" cy="566928"/>
+            <a:off x="1234440" y="4306823"/>
+            <a:ext cx="320040" cy="320040"/>
           </a:xfrm>
           <a:prstGeom prst="rect">
             <a:avLst/>
@@ -6659,26 +6340,26 @@
           <a:p>
             <a:pPr algn="ctr"/>
             <a:r>
-              <a:rPr sz="3400" b="1">
-                <a:solidFill>
-                  <a:srgbClr val="FFFFFF"/>
+              <a:rPr sz="1700" b="1">
+                <a:solidFill>
+                  <a:srgbClr val="A1A1AA"/>
                 </a:solidFill>
               </a:rPr>
-              <a:t>Try it next</a:t>
-            </a:r>
-          </a:p>
-        </p:txBody>
-      </p:sp>
-      <p:sp>
-        <p:nvSpPr>
-          <p:cNvPr id="3" name="TextBox 2"/>
+              <a:t>4</a:t>
+            </a:r>
+          </a:p>
+        </p:txBody>
+      </p:sp>
+      <p:sp>
+        <p:nvSpPr>
+          <p:cNvPr id="11" name="TextBox 10"/>
           <p:cNvSpPr txBox="1"/>
           <p:nvPr/>
         </p:nvSpPr>
         <p:spPr>
           <a:xfrm>
-            <a:off x="1097280" y="1481328"/>
-            <a:ext cx="9966960" cy="502920"/>
+            <a:off x="1700784" y="4279391"/>
+            <a:ext cx="9144000" cy="502920"/>
           </a:xfrm>
           <a:prstGeom prst="rect">
             <a:avLst/>
@@ -6691,286 +6372,14 @@
           </a:bodyPr>
           <a:lstStyle/>
           <a:p>
-            <a:pPr algn="ctr"/>
-            <a:r>
-              <a:rPr sz="2000" b="0">
-                <a:solidFill>
-                  <a:srgbClr val="A1A1AA"/>
+            <a:pPr algn="l"/>
+            <a:r>
+              <a:rPr sz="1700" b="0">
+                <a:solidFill>
+                  <a:srgbClr val="FFFFFF"/>
                 </a:solidFill>
               </a:rPr>
-              <a:t>Write a production runbook for the Chapter 6 invoice pipeline.</a:t>
-            </a:r>
-          </a:p>
-        </p:txBody>
-      </p:sp>
-      <p:sp>
-        <p:nvSpPr>
-          <p:cNvPr id="4" name="TextBox 3"/>
-          <p:cNvSpPr txBox="1"/>
-          <p:nvPr/>
-        </p:nvSpPr>
-        <p:spPr>
-          <a:xfrm>
-            <a:off x="1234440" y="2331720"/>
-            <a:ext cx="320040" cy="320040"/>
-          </a:xfrm>
-          <a:prstGeom prst="rect">
-            <a:avLst/>
-          </a:prstGeom>
-          <a:noFill/>
-        </p:spPr>
-        <p:txBody>
-          <a:bodyPr wrap="square" lIns="18288" rIns="18288">
-            <a:normAutofit/>
-          </a:bodyPr>
-          <a:lstStyle/>
-          <a:p>
-            <a:pPr algn="ctr"/>
-            <a:r>
-              <a:rPr sz="1700" b="1">
-                <a:solidFill>
-                  <a:srgbClr val="A1A1AA"/>
-                </a:solidFill>
-              </a:rPr>
-              <a:t>1</a:t>
-            </a:r>
-          </a:p>
-        </p:txBody>
-      </p:sp>
-      <p:sp>
-        <p:nvSpPr>
-          <p:cNvPr id="5" name="TextBox 4"/>
-          <p:cNvSpPr txBox="1"/>
-          <p:nvPr/>
-        </p:nvSpPr>
-        <p:spPr>
-          <a:xfrm>
-            <a:off x="1700784" y="2304288"/>
-            <a:ext cx="9144000" cy="502920"/>
-          </a:xfrm>
-          <a:prstGeom prst="rect">
-            <a:avLst/>
-          </a:prstGeom>
-          <a:noFill/>
-        </p:spPr>
-        <p:txBody>
-          <a:bodyPr wrap="square" lIns="18288" rIns="18288">
-            <a:normAutofit/>
-          </a:bodyPr>
-          <a:lstStyle/>
-          <a:p>
-            <a:pPr algn="l"/>
-            <a:r>
-              <a:rPr sz="1700" b="0">
-                <a:solidFill>
-                  <a:srgbClr val="FFFFFF"/>
-                </a:solidFill>
-              </a:rPr>
-              <a:t>Define p50, p99, availability, and max cost-per-invoice targets with justification.</a:t>
-            </a:r>
-          </a:p>
-        </p:txBody>
-      </p:sp>
-      <p:sp>
-        <p:nvSpPr>
-          <p:cNvPr id="6" name="TextBox 5"/>
-          <p:cNvSpPr txBox="1"/>
-          <p:nvPr/>
-        </p:nvSpPr>
-        <p:spPr>
-          <a:xfrm>
-            <a:off x="1234440" y="2990087"/>
-            <a:ext cx="320040" cy="320040"/>
-          </a:xfrm>
-          <a:prstGeom prst="rect">
-            <a:avLst/>
-          </a:prstGeom>
-          <a:noFill/>
-        </p:spPr>
-        <p:txBody>
-          <a:bodyPr wrap="square" lIns="18288" rIns="18288">
-            <a:normAutofit/>
-          </a:bodyPr>
-          <a:lstStyle/>
-          <a:p>
-            <a:pPr algn="ctr"/>
-            <a:r>
-              <a:rPr sz="1700" b="1">
-                <a:solidFill>
-                  <a:srgbClr val="A1A1AA"/>
-                </a:solidFill>
-              </a:rPr>
-              <a:t>2</a:t>
-            </a:r>
-          </a:p>
-        </p:txBody>
-      </p:sp>
-      <p:sp>
-        <p:nvSpPr>
-          <p:cNvPr id="7" name="TextBox 6"/>
-          <p:cNvSpPr txBox="1"/>
-          <p:nvPr/>
-        </p:nvSpPr>
-        <p:spPr>
-          <a:xfrm>
-            <a:off x="1700784" y="2962656"/>
-            <a:ext cx="9144000" cy="502920"/>
-          </a:xfrm>
-          <a:prstGeom prst="rect">
-            <a:avLst/>
-          </a:prstGeom>
-          <a:noFill/>
-        </p:spPr>
-        <p:txBody>
-          <a:bodyPr wrap="square" lIns="18288" rIns="18288">
-            <a:normAutofit/>
-          </a:bodyPr>
-          <a:lstStyle/>
-          <a:p>
-            <a:pPr algn="l"/>
-            <a:r>
-              <a:rPr sz="1700" b="0">
-                <a:solidFill>
-                  <a:srgbClr val="FFFFFF"/>
-                </a:solidFill>
-              </a:rPr>
-              <a:t>Project launch and 6-month capacity, including the PT decision point.</a:t>
-            </a:r>
-          </a:p>
-        </p:txBody>
-      </p:sp>
-      <p:sp>
-        <p:nvSpPr>
-          <p:cNvPr id="8" name="TextBox 7"/>
-          <p:cNvSpPr txBox="1"/>
-          <p:nvPr/>
-        </p:nvSpPr>
-        <p:spPr>
-          <a:xfrm>
-            <a:off x="1234440" y="3648455"/>
-            <a:ext cx="320040" cy="320040"/>
-          </a:xfrm>
-          <a:prstGeom prst="rect">
-            <a:avLst/>
-          </a:prstGeom>
-          <a:noFill/>
-        </p:spPr>
-        <p:txBody>
-          <a:bodyPr wrap="square" lIns="18288" rIns="18288">
-            <a:normAutofit/>
-          </a:bodyPr>
-          <a:lstStyle/>
-          <a:p>
-            <a:pPr algn="ctr"/>
-            <a:r>
-              <a:rPr sz="1700" b="1">
-                <a:solidFill>
-                  <a:srgbClr val="A1A1AA"/>
-                </a:solidFill>
-              </a:rPr>
-              <a:t>3</a:t>
-            </a:r>
-          </a:p>
-        </p:txBody>
-      </p:sp>
-      <p:sp>
-        <p:nvSpPr>
-          <p:cNvPr id="9" name="TextBox 8"/>
-          <p:cNvSpPr txBox="1"/>
-          <p:nvPr/>
-        </p:nvSpPr>
-        <p:spPr>
-          <a:xfrm>
-            <a:off x="1700784" y="3621023"/>
-            <a:ext cx="9144000" cy="502920"/>
-          </a:xfrm>
-          <a:prstGeom prst="rect">
-            <a:avLst/>
-          </a:prstGeom>
-          <a:noFill/>
-        </p:spPr>
-        <p:txBody>
-          <a:bodyPr wrap="square" lIns="18288" rIns="18288">
-            <a:normAutofit/>
-          </a:bodyPr>
-          <a:lstStyle/>
-          <a:p>
-            <a:pPr algn="l"/>
-            <a:r>
-              <a:rPr sz="1700" b="0">
-                <a:solidFill>
-                  <a:srgbClr val="FFFFFF"/>
-                </a:solidFill>
-              </a:rPr>
-              <a:t>Break down Pro tokens, Flash tokens, runtime hours, storage, and audit-log retention.</a:t>
-            </a:r>
-          </a:p>
-        </p:txBody>
-      </p:sp>
-      <p:sp>
-        <p:nvSpPr>
-          <p:cNvPr id="10" name="TextBox 9"/>
-          <p:cNvSpPr txBox="1"/>
-          <p:nvPr/>
-        </p:nvSpPr>
-        <p:spPr>
-          <a:xfrm>
-            <a:off x="1234440" y="4306823"/>
-            <a:ext cx="320040" cy="320040"/>
-          </a:xfrm>
-          <a:prstGeom prst="rect">
-            <a:avLst/>
-          </a:prstGeom>
-          <a:noFill/>
-        </p:spPr>
-        <p:txBody>
-          <a:bodyPr wrap="square" lIns="18288" rIns="18288">
-            <a:normAutofit/>
-          </a:bodyPr>
-          <a:lstStyle/>
-          <a:p>
-            <a:pPr algn="ctr"/>
-            <a:r>
-              <a:rPr sz="1700" b="1">
-                <a:solidFill>
-                  <a:srgbClr val="A1A1AA"/>
-                </a:solidFill>
-              </a:rPr>
-              <a:t>4</a:t>
-            </a:r>
-          </a:p>
-        </p:txBody>
-      </p:sp>
-      <p:sp>
-        <p:nvSpPr>
-          <p:cNvPr id="11" name="TextBox 10"/>
-          <p:cNvSpPr txBox="1"/>
-          <p:nvPr/>
-        </p:nvSpPr>
-        <p:spPr>
-          <a:xfrm>
-            <a:off x="1700784" y="4279391"/>
-            <a:ext cx="9144000" cy="502920"/>
-          </a:xfrm>
-          <a:prstGeom prst="rect">
-            <a:avLst/>
-          </a:prstGeom>
-          <a:noFill/>
-        </p:spPr>
-        <p:txBody>
-          <a:bodyPr wrap="square" lIns="18288" rIns="18288">
-            <a:normAutofit/>
-          </a:bodyPr>
-          <a:lstStyle/>
-          <a:p>
-            <a:pPr algn="l"/>
-            <a:r>
-              <a:rPr sz="1700" b="0">
-                <a:solidFill>
-                  <a:srgbClr val="FFFFFF"/>
-                </a:solidFill>
-              </a:rPr>
-              <a:t>Document quotas, autoscaling profile, labels, rollback steps, and three failure scenarios.</a:t>
+              <a:t>Add mandatory cost labels and a monthly billing-export query for chargeback reporting.</a:t>
             </a:r>
           </a:p>
         </p:txBody>

</xml_diff>